<commit_message>
Rebuild the correlation and pipeline slides
Correlation was written while the tab was broken, so it could only
describe the three methods in text. Now that regime correlation
actually computes, the slide leads with the finding: a clustered bar
chart of calm vs stressed correlation to the S&P 500 for all six
coins, against the misleading +0.07 full-sample figure. Every coin
rises under stress without exception. Bar values use the app's own
2dp display figures so the slide and the live dashboard read
identically when shown side by side.

Pipeline replaced the reused SRS report figure — which carried a
different font, palette and background from the rest of the deck —
with a native five-stage flow in the deck's own styling, with the
MarketData bundle accent-filled as the hub.

Co-Authored-By: Claude Opus 5 <noreply@anthropic.com>
</commit_message>
<xml_diff>
--- a/docs/Crypto_Market_Analysis_Final_Evaluation.pptx
+++ b/docs/Crypto_Market_Analysis_Final_Evaluation.pptx
@@ -761,6 +761,385 @@
 </file>
 
 <file path=ppt/charts/chart3.xml><?xml version="1.0" encoding="utf-8"?>
+<c:chartSpace xmlns:c="http://schemas.openxmlformats.org/drawingml/2006/chart" xmlns:a="http://schemas.openxmlformats.org/drawingml/2006/main" xmlns:r="http://schemas.openxmlformats.org/officeDocument/2006/relationships">
+  <c:date1904 val="0"/>
+  <c:roundedCorners val="1"/>
+  <c:chart>
+    <c:autoTitleDeleted val="1"/>
+    <c:plotArea>
+      <c:layout/>
+      <c:barChart>
+        <c:barDir val="col"/>
+        <c:grouping val="clustered"/>
+        <c:varyColors val="0"/>
+        <c:ser>
+          <c:idx val="0"/>
+          <c:order val="0"/>
+          <c:tx>
+            <c:strRef>
+              <c:f>Sheet1!$B$1</c:f>
+              <c:strCache>
+                <c:ptCount val="1"/>
+                <c:pt idx="0">
+                  <c:v>Calm  (225 days)</c:v>
+                </c:pt>
+              </c:strCache>
+            </c:strRef>
+          </c:tx>
+          <c:spPr>
+            <a:solidFill>
+              <a:srgbClr val="A8B8C0"/>
+            </a:solidFill>
+            <a:effectLst/>
+          </c:spPr>
+          <c:invertIfNegative val="0"/>
+          <c:dLbls>
+            <c:numFmt formatCode="0.00" sourceLinked="0"/>
+            <c:txPr>
+              <a:bodyPr/>
+              <a:lstStyle/>
+              <a:p>
+                <a:pPr>
+                  <a:defRPr b="0" i="0" strike="noStrike" sz="950" u="none">
+                    <a:solidFill>
+                      <a:srgbClr val="16202A"/>
+                    </a:solidFill>
+                    <a:latin typeface="Arial"/>
+                  </a:defRPr>
+                </a:pPr>
+              </a:p>
+            </c:txPr>
+            <c:showLegendKey val="0"/>
+            <c:showVal val="1"/>
+            <c:showCatName val="0"/>
+            <c:showSerName val="0"/>
+            <c:showPercent val="0"/>
+            <c:showBubbleSize val="0"/>
+            <c:showLeaderLines val="0"/>
+          </c:dLbls>
+          <c:cat>
+            <c:multiLvlStrRef>
+              <c:f>Sheet1!$A$2:$A$7</c:f>
+              <c:multiLvlStrCache>
+                <c:ptCount val="6"/>
+                <c:lvl>
+                  <c:pt idx="0">
+                    <c:v>BTC</c:v>
+                  </c:pt>
+                  <c:pt idx="1">
+                    <c:v>ETH</c:v>
+                  </c:pt>
+                  <c:pt idx="2">
+                    <c:v>SOL</c:v>
+                  </c:pt>
+                  <c:pt idx="3">
+                    <c:v>BNB</c:v>
+                  </c:pt>
+                  <c:pt idx="4">
+                    <c:v>XRP</c:v>
+                  </c:pt>
+                  <c:pt idx="5">
+                    <c:v>ADA</c:v>
+                  </c:pt>
+                </c:lvl>
+              </c:multiLvlStrCache>
+            </c:multiLvlStrRef>
+          </c:cat>
+          <c:val>
+            <c:numRef>
+              <c:f>Sheet1!$B$2:$B$7</c:f>
+              <c:numCache>
+                <c:formatCode>General</c:formatCode>
+                <c:ptCount val="6"/>
+                <c:pt idx="0">
+                  <c:v>0</c:v>
+                </c:pt>
+                <c:pt idx="1">
+                  <c:v>-0.01</c:v>
+                </c:pt>
+                <c:pt idx="2">
+                  <c:v>0.03</c:v>
+                </c:pt>
+                <c:pt idx="3">
+                  <c:v>-0.01</c:v>
+                </c:pt>
+                <c:pt idx="4">
+                  <c:v>0.03</c:v>
+                </c:pt>
+                <c:pt idx="5">
+                  <c:v>0.1</c:v>
+                </c:pt>
+              </c:numCache>
+            </c:numRef>
+          </c:val>
+        </c:ser>
+        <c:ser>
+          <c:idx val="1"/>
+          <c:order val="1"/>
+          <c:tx>
+            <c:strRef>
+              <c:f>Sheet1!$C$1</c:f>
+              <c:strCache>
+                <c:ptCount val="1"/>
+                <c:pt idx="0">
+                  <c:v>Stressed  (25 days)</c:v>
+                </c:pt>
+              </c:strCache>
+            </c:strRef>
+          </c:tx>
+          <c:spPr>
+            <a:solidFill>
+              <a:srgbClr val="E85D5D"/>
+            </a:solidFill>
+            <a:effectLst/>
+          </c:spPr>
+          <c:invertIfNegative val="0"/>
+          <c:dLbls>
+            <c:numFmt formatCode="0.00" sourceLinked="0"/>
+            <c:txPr>
+              <a:bodyPr/>
+              <a:lstStyle/>
+              <a:p>
+                <a:pPr>
+                  <a:defRPr b="0" i="0" strike="noStrike" sz="950" u="none">
+                    <a:solidFill>
+                      <a:srgbClr val="16202A"/>
+                    </a:solidFill>
+                    <a:latin typeface="Arial"/>
+                  </a:defRPr>
+                </a:pPr>
+              </a:p>
+            </c:txPr>
+            <c:showLegendKey val="0"/>
+            <c:showVal val="1"/>
+            <c:showCatName val="0"/>
+            <c:showSerName val="0"/>
+            <c:showPercent val="0"/>
+            <c:showBubbleSize val="0"/>
+            <c:showLeaderLines val="0"/>
+          </c:dLbls>
+          <c:cat>
+            <c:multiLvlStrRef>
+              <c:f>Sheet1!$A$2:$A$7</c:f>
+              <c:multiLvlStrCache>
+                <c:ptCount val="6"/>
+                <c:lvl>
+                  <c:pt idx="0">
+                    <c:v>BTC</c:v>
+                  </c:pt>
+                  <c:pt idx="1">
+                    <c:v>ETH</c:v>
+                  </c:pt>
+                  <c:pt idx="2">
+                    <c:v>SOL</c:v>
+                  </c:pt>
+                  <c:pt idx="3">
+                    <c:v>BNB</c:v>
+                  </c:pt>
+                  <c:pt idx="4">
+                    <c:v>XRP</c:v>
+                  </c:pt>
+                  <c:pt idx="5">
+                    <c:v>ADA</c:v>
+                  </c:pt>
+                </c:lvl>
+              </c:multiLvlStrCache>
+            </c:multiLvlStrRef>
+          </c:cat>
+          <c:val>
+            <c:numRef>
+              <c:f>Sheet1!$C$2:$C$7</c:f>
+              <c:numCache>
+                <c:formatCode>General</c:formatCode>
+                <c:ptCount val="6"/>
+                <c:pt idx="0">
+                  <c:v>0.12</c:v>
+                </c:pt>
+                <c:pt idx="1">
+                  <c:v>0.17</c:v>
+                </c:pt>
+                <c:pt idx="2">
+                  <c:v>0.21</c:v>
+                </c:pt>
+                <c:pt idx="3">
+                  <c:v>0.09</c:v>
+                </c:pt>
+                <c:pt idx="4">
+                  <c:v>0.2</c:v>
+                </c:pt>
+                <c:pt idx="5">
+                  <c:v>0.32</c:v>
+                </c:pt>
+              </c:numCache>
+            </c:numRef>
+          </c:val>
+        </c:ser>
+        <c:dLbls>
+          <c:numFmt formatCode="0.00" sourceLinked="0"/>
+          <c:txPr>
+            <a:bodyPr/>
+            <a:lstStyle/>
+            <a:p>
+              <a:pPr>
+                <a:defRPr b="0" i="0" strike="noStrike" sz="950" u="none">
+                  <a:solidFill>
+                    <a:srgbClr val="16202A"/>
+                  </a:solidFill>
+                  <a:latin typeface="Arial"/>
+                </a:defRPr>
+              </a:pPr>
+            </a:p>
+          </c:txPr>
+          <c:showLegendKey val="0"/>
+          <c:showVal val="1"/>
+          <c:showCatName val="0"/>
+          <c:showSerName val="0"/>
+          <c:showPercent val="0"/>
+          <c:showBubbleSize val="0"/>
+          <c:showLeaderLines val="0"/>
+        </c:dLbls>
+        <c:gapWidth val="55"/>
+        <c:overlap val="0"/>
+        <c:axId val="2094734554"/>
+        <c:axId val="2094734552"/>
+        <c:axId val="2094734556"/>
+      </c:barChart>
+      <c:catAx>
+        <c:axId val="2094734554"/>
+        <c:scaling>
+          <c:orientation val="minMax"/>
+        </c:scaling>
+        <c:delete val="0"/>
+        <c:axPos val="b"/>
+        <c:numFmt formatCode="General" sourceLinked="1"/>
+        <c:majorTickMark val="out"/>
+        <c:minorTickMark val="none"/>
+        <c:tickLblPos val="low"/>
+        <c:spPr>
+          <a:ln w="12700" cap="flat">
+            <a:solidFill>
+              <a:srgbClr val="DCE4E6"/>
+            </a:solidFill>
+            <a:prstDash val="solid"/>
+            <a:round/>
+          </a:ln>
+        </c:spPr>
+        <c:txPr>
+          <a:bodyPr/>
+          <a:lstStyle/>
+          <a:p>
+            <a:pPr>
+              <a:defRPr sz="1150" b="1" i="0" u="none" strike="noStrike">
+                <a:solidFill>
+                  <a:srgbClr val="16202A"/>
+                </a:solidFill>
+                <a:latin typeface="Arial"/>
+              </a:defRPr>
+            </a:pPr>
+            <a:endParaRPr lang="en-US"/>
+          </a:p>
+        </c:txPr>
+        <c:crossAx val="2094734552"/>
+        <c:crosses val="autoZero"/>
+        <c:auto val="1"/>
+        <c:lblAlgn val="ctr"/>
+        <c:noMultiLvlLbl val="1"/>
+      </c:catAx>
+      <c:valAx>
+        <c:axId val="2094734552"/>
+        <c:scaling>
+          <c:orientation val="minMax"/>
+          <c:max val="0.38"/>
+          <c:min val="-0.06"/>
+        </c:scaling>
+        <c:delete val="0"/>
+        <c:axPos val="l"/>
+        <c:majorGridlines>
+          <c:spPr>
+            <a:ln w="9525" cap="flat">
+              <a:solidFill>
+                <a:srgbClr val="E8EDEF"/>
+              </a:solidFill>
+              <a:prstDash val="solid"/>
+              <a:round/>
+            </a:ln>
+          </c:spPr>
+        </c:majorGridlines>
+        <c:numFmt formatCode="0.0" sourceLinked="0"/>
+        <c:majorTickMark val="out"/>
+        <c:minorTickMark val="none"/>
+        <c:tickLblPos val="nextTo"/>
+        <c:spPr>
+          <a:ln w="12700" cap="flat">
+            <a:solidFill>
+              <a:srgbClr val="DCE4E6"/>
+            </a:solidFill>
+            <a:prstDash val="solid"/>
+            <a:round/>
+          </a:ln>
+        </c:spPr>
+        <c:txPr>
+          <a:bodyPr/>
+          <a:lstStyle/>
+          <a:p>
+            <a:pPr>
+              <a:defRPr sz="900" b="0" i="0" u="none" strike="noStrike">
+                <a:solidFill>
+                  <a:srgbClr val="5B6B76"/>
+                </a:solidFill>
+                <a:latin typeface="Arial"/>
+              </a:defRPr>
+            </a:pPr>
+            <a:endParaRPr lang="en-US"/>
+          </a:p>
+        </c:txPr>
+        <c:crossAx val="2094734554"/>
+        <c:crosses val="autoZero"/>
+        <c:crossBetween val="between"/>
+      </c:valAx>
+      <c:spPr>
+        <a:noFill/>
+        <a:ln>
+          <a:noFill/>
+        </a:ln>
+        <a:effectLst/>
+      </c:spPr>
+    </c:plotArea>
+    <c:legend>
+      <c:legendPos val="t"/>
+      <c:overlay val="0"/>
+      <c:txPr>
+        <a:bodyPr/>
+        <a:lstStyle/>
+        <a:p>
+          <a:pPr>
+            <a:defRPr sz="1050">
+              <a:solidFill>
+                <a:srgbClr val="5B6B76"/>
+              </a:solidFill>
+            </a:defRPr>
+          </a:pPr>
+          <a:endParaRPr lang="en-US"/>
+        </a:p>
+      </c:txPr>
+    </c:legend>
+    <c:plotVisOnly val="1"/>
+    <c:dispBlanksAs val="span"/>
+  </c:chart>
+  <c:spPr>
+    <a:noFill/>
+    <a:ln>
+      <a:noFill/>
+    </a:ln>
+    <a:effectLst/>
+  </c:spPr>
+  <c:externalData r:id="rId1">
+    <c:autoUpdate val="0"/>
+  </c:externalData>
+</c:chartSpace>
+</file>
+
+<file path=ppt/charts/chart4.xml><?xml version="1.0" encoding="utf-8"?>
 <c:chartSpace xmlns:c="http://schemas.openxmlformats.org/drawingml/2006/chart" xmlns:a="http://schemas.openxmlformats.org/drawingml/2006/main" xmlns:r="http://schemas.openxmlformats.org/officeDocument/2006/relationships">
   <c:date1904 val="0"/>
   <c:roundedCorners val="1"/>
@@ -12194,7 +12573,7 @@
                 <a:ea typeface="Calibri" pitchFamily="34" charset="-122"/>
                 <a:cs typeface="Calibri" pitchFamily="34" charset="-120"/>
               </a:rPr>
-              <a:t>Does crypto move with traditional markets, or on its own? The answer changes with the regime — so we measure it three ways.</a:t>
+              <a:t>Does crypto actually diversify a portfolio? A single number says yes. Splitting the sample says otherwise.</a:t>
             </a:r>
             <a:endParaRPr lang="en-US" sz="1300" dirty="0"/>
           </a:p>
@@ -12202,143 +12581,78 @@
       </p:sp>
       <p:sp>
         <p:nvSpPr>
-          <p:cNvPr id="5" name="Shape 3"/>
-          <p:cNvSpPr/>
-          <p:nvPr/>
-        </p:nvSpPr>
-        <p:spPr>
-          <a:xfrm>
-            <a:off x="548640" y="1691640"/>
-            <a:ext cx="10607040" cy="932688"/>
-          </a:xfrm>
-          <a:prstGeom prst="roundRect">
-            <a:avLst>
-              <a:gd name="adj" fmla="val 7843"/>
-            </a:avLst>
-          </a:prstGeom>
-          <a:solidFill>
-            <a:srgbClr val="F1F5F6"/>
-          </a:solidFill>
-          <a:ln/>
-        </p:spPr>
-      </p:sp>
-      <p:sp>
-        <p:nvSpPr>
-          <p:cNvPr id="6" name="Shape 4"/>
-          <p:cNvSpPr/>
-          <p:nvPr/>
-        </p:nvSpPr>
-        <p:spPr>
-          <a:xfrm>
-            <a:off x="777240" y="1865376"/>
-            <a:ext cx="585216" cy="585216"/>
-          </a:xfrm>
-          <a:prstGeom prst="ellipse">
-            <a:avLst/>
-          </a:prstGeom>
-          <a:solidFill>
-            <a:srgbClr val="00BCD4"/>
-          </a:solidFill>
-          <a:ln/>
-        </p:spPr>
-      </p:sp>
-      <p:sp>
-        <p:nvSpPr>
-          <p:cNvPr id="7" name="Text 5"/>
-          <p:cNvSpPr/>
-          <p:nvPr/>
-        </p:nvSpPr>
-        <p:spPr>
-          <a:xfrm>
-            <a:off x="777240" y="1865376"/>
-            <a:ext cx="585216" cy="585216"/>
-          </a:xfrm>
-          <a:prstGeom prst="rect">
-            <a:avLst/>
-          </a:prstGeom>
-          <a:noFill/>
-          <a:ln/>
-        </p:spPr>
-        <p:txBody>
-          <a:bodyPr wrap="square" rtlCol="0" anchor="ctr"/>
-          <a:lstStyle/>
-          <a:p>
-            <a:pPr algn="ctr" indent="0" marL="0">
-              <a:buNone/>
-            </a:pPr>
-            <a:r>
-              <a:rPr lang="en-US" sz="1600" b="1" dirty="0">
-                <a:solidFill>
-                  <a:srgbClr val="14181C"/>
-                </a:solidFill>
-                <a:latin typeface="Calibri" pitchFamily="34" charset="0"/>
-                <a:ea typeface="Calibri" pitchFamily="34" charset="-122"/>
-                <a:cs typeface="Calibri" pitchFamily="34" charset="-120"/>
-              </a:rPr>
-              <a:t>⇄</a:t>
-            </a:r>
-            <a:endParaRPr lang="en-US" sz="1600" dirty="0"/>
-          </a:p>
-        </p:txBody>
-      </p:sp>
-      <p:sp>
-        <p:nvSpPr>
-          <p:cNvPr id="8" name="Text 6"/>
-          <p:cNvSpPr/>
-          <p:nvPr/>
-        </p:nvSpPr>
-        <p:spPr>
-          <a:xfrm>
-            <a:off x="1600200" y="1783080"/>
-            <a:ext cx="2743200" cy="749808"/>
-          </a:xfrm>
-          <a:prstGeom prst="rect">
-            <a:avLst/>
-          </a:prstGeom>
-          <a:noFill/>
-          <a:ln/>
-        </p:spPr>
-        <p:txBody>
-          <a:bodyPr wrap="square" rtlCol="0" anchor="ctr"/>
+          <p:cNvPr id="5" name="Text 3"/>
+          <p:cNvSpPr/>
+          <p:nvPr/>
+        </p:nvSpPr>
+        <p:spPr>
+          <a:xfrm>
+            <a:off x="548640" y="1572768"/>
+            <a:ext cx="6949440" cy="292608"/>
+          </a:xfrm>
+          <a:prstGeom prst="rect">
+            <a:avLst/>
+          </a:prstGeom>
+          <a:noFill/>
+          <a:ln/>
+        </p:spPr>
+        <p:txBody>
+          <a:bodyPr wrap="square" lIns="0" tIns="0" rIns="0" bIns="0" rtlCol="0" anchor="ctr"/>
           <a:lstStyle/>
           <a:p>
             <a:pPr indent="0" marL="0">
               <a:buNone/>
             </a:pPr>
             <a:r>
-              <a:rPr lang="en-US" sz="1400" b="1" dirty="0">
-                <a:solidFill>
-                  <a:srgbClr val="16202A"/>
-                </a:solidFill>
-                <a:latin typeface="Calibri" pitchFamily="34" charset="0"/>
-                <a:ea typeface="Calibri" pitchFamily="34" charset="-122"/>
-                <a:cs typeface="Calibri" pitchFamily="34" charset="-120"/>
-              </a:rPr>
-              <a:t>Static Correlation</a:t>
-            </a:r>
-            <a:endParaRPr lang="en-US" sz="1400" dirty="0"/>
-          </a:p>
-        </p:txBody>
-      </p:sp>
-      <p:sp>
-        <p:nvSpPr>
-          <p:cNvPr id="9" name="Text 7"/>
-          <p:cNvSpPr/>
-          <p:nvPr/>
-        </p:nvSpPr>
-        <p:spPr>
-          <a:xfrm>
-            <a:off x="4480560" y="1783080"/>
-            <a:ext cx="6492240" cy="749808"/>
-          </a:xfrm>
-          <a:prstGeom prst="rect">
-            <a:avLst/>
-          </a:prstGeom>
-          <a:noFill/>
-          <a:ln/>
-        </p:spPr>
-        <p:txBody>
-          <a:bodyPr wrap="square" rtlCol="0" anchor="ctr"/>
+              <a:rPr lang="en-US" sz="1100" b="1" spc="50" kern="0" dirty="0">
+                <a:solidFill>
+                  <a:srgbClr val="0097A7"/>
+                </a:solidFill>
+                <a:latin typeface="Calibri" pitchFamily="34" charset="0"/>
+                <a:ea typeface="Calibri" pitchFamily="34" charset="-122"/>
+                <a:cs typeface="Calibri" pitchFamily="34" charset="-120"/>
+              </a:rPr>
+              <a:t>Correlation to the S&amp;P 500 — calm markets vs. the worst 10% of equity days</a:t>
+            </a:r>
+            <a:endParaRPr lang="en-US" sz="1100" dirty="0"/>
+          </a:p>
+        </p:txBody>
+      </p:sp>
+      <p:graphicFrame>
+        <p:nvGraphicFramePr>
+          <p:cNvPr id="6" name="Chart 0" descr=""/>
+          <p:cNvGraphicFramePr/>
+          <p:nvPr/>
+        </p:nvGraphicFramePr>
+        <p:xfrm>
+          <a:off x="457200" y="1920240"/>
+          <a:ext cx="7132320" cy="3429000"/>
+        </p:xfrm>
+        <a:graphic xmlns:a="http://schemas.openxmlformats.org/drawingml/2006/main">
+          <a:graphicData uri="http://schemas.openxmlformats.org/drawingml/2006/chart">
+            <c:chart xmlns:c="http://schemas.openxmlformats.org/drawingml/2006/chart" r:id="rId1"/>
+          </a:graphicData>
+        </a:graphic>
+      </p:graphicFrame>
+      <p:sp>
+        <p:nvSpPr>
+          <p:cNvPr id="7" name="Text 4"/>
+          <p:cNvSpPr/>
+          <p:nvPr/>
+        </p:nvSpPr>
+        <p:spPr>
+          <a:xfrm>
+            <a:off x="548640" y="5440680"/>
+            <a:ext cx="6949440" cy="502920"/>
+          </a:xfrm>
+          <a:prstGeom prst="rect">
+            <a:avLst/>
+          </a:prstGeom>
+          <a:noFill/>
+          <a:ln/>
+        </p:spPr>
+        <p:txBody>
+          <a:bodyPr wrap="square" lIns="0" tIns="0" rIns="0" bIns="0" rtlCol="0" anchor="ctr"/>
           <a:lstStyle/>
           <a:p>
             <a:pPr indent="0" marL="0">
@@ -12348,7 +12662,7 @@
               <a:buNone/>
             </a:pPr>
             <a:r>
-              <a:rPr lang="en-US" sz="1200" dirty="0">
+              <a:rPr lang="en-US" sz="1150" i="1" dirty="0">
                 <a:solidFill>
                   <a:srgbClr val="5B6B76"/>
                 </a:solidFill>
@@ -12356,26 +12670,26 @@
                 <a:ea typeface="Calibri" pitchFamily="34" charset="-122"/>
                 <a:cs typeface="Calibri" pitchFamily="34" charset="-120"/>
               </a:rPr>
-              <a:t>Pearson correlation of daily returns across all 6 coins and 5 macro assets, side by side in one matrix</a:t>
-            </a:r>
-            <a:endParaRPr lang="en-US" sz="1200" dirty="0"/>
-          </a:p>
-        </p:txBody>
-      </p:sp>
-      <p:sp>
-        <p:nvSpPr>
-          <p:cNvPr id="10" name="Shape 8"/>
-          <p:cNvSpPr/>
-          <p:nvPr/>
-        </p:nvSpPr>
-        <p:spPr>
-          <a:xfrm>
-            <a:off x="548640" y="2788920"/>
-            <a:ext cx="10607040" cy="932688"/>
+              <a:t>Every coin — no exceptions — becomes more correlated with equities on the days equities fall hardest.</a:t>
+            </a:r>
+            <a:endParaRPr lang="en-US" sz="1150" dirty="0"/>
+          </a:p>
+        </p:txBody>
+      </p:sp>
+      <p:sp>
+        <p:nvSpPr>
+          <p:cNvPr id="8" name="Shape 5"/>
+          <p:cNvSpPr/>
+          <p:nvPr/>
+        </p:nvSpPr>
+        <p:spPr>
+          <a:xfrm>
+            <a:off x="7818120" y="1572768"/>
+            <a:ext cx="3840480" cy="1600200"/>
           </a:xfrm>
           <a:prstGeom prst="roundRect">
             <a:avLst>
-              <a:gd name="adj" fmla="val 7843"/>
+              <a:gd name="adj" fmla="val 4571"/>
             </a:avLst>
           </a:prstGeom>
           <a:solidFill>
@@ -12386,121 +12700,101 @@
       </p:sp>
       <p:sp>
         <p:nvSpPr>
-          <p:cNvPr id="11" name="Shape 9"/>
-          <p:cNvSpPr/>
-          <p:nvPr/>
-        </p:nvSpPr>
-        <p:spPr>
-          <a:xfrm>
-            <a:off x="777240" y="2962656"/>
-            <a:ext cx="585216" cy="585216"/>
-          </a:xfrm>
-          <a:prstGeom prst="ellipse">
-            <a:avLst/>
-          </a:prstGeom>
-          <a:solidFill>
-            <a:srgbClr val="00BCD4"/>
-          </a:solidFill>
-          <a:ln/>
-        </p:spPr>
-      </p:sp>
-      <p:sp>
-        <p:nvSpPr>
-          <p:cNvPr id="12" name="Text 10"/>
-          <p:cNvSpPr/>
-          <p:nvPr/>
-        </p:nvSpPr>
-        <p:spPr>
-          <a:xfrm>
-            <a:off x="777240" y="2962656"/>
-            <a:ext cx="585216" cy="585216"/>
-          </a:xfrm>
-          <a:prstGeom prst="rect">
-            <a:avLst/>
-          </a:prstGeom>
-          <a:noFill/>
-          <a:ln/>
-        </p:spPr>
-        <p:txBody>
-          <a:bodyPr wrap="square" rtlCol="0" anchor="ctr"/>
-          <a:lstStyle/>
-          <a:p>
-            <a:pPr algn="ctr" indent="0" marL="0">
-              <a:buNone/>
-            </a:pPr>
-            <a:r>
-              <a:rPr lang="en-US" sz="1600" b="1" dirty="0">
-                <a:solidFill>
-                  <a:srgbClr val="14181C"/>
-                </a:solidFill>
-                <a:latin typeface="Calibri" pitchFamily="34" charset="0"/>
-                <a:ea typeface="Calibri" pitchFamily="34" charset="-122"/>
-                <a:cs typeface="Calibri" pitchFamily="34" charset="-120"/>
-              </a:rPr>
-              <a:t>⇄</a:t>
-            </a:r>
-            <a:endParaRPr lang="en-US" sz="1600" dirty="0"/>
-          </a:p>
-        </p:txBody>
-      </p:sp>
-      <p:sp>
-        <p:nvSpPr>
-          <p:cNvPr id="13" name="Text 11"/>
-          <p:cNvSpPr/>
-          <p:nvPr/>
-        </p:nvSpPr>
-        <p:spPr>
-          <a:xfrm>
-            <a:off x="1600200" y="2880360"/>
-            <a:ext cx="2743200" cy="749808"/>
-          </a:xfrm>
-          <a:prstGeom prst="rect">
-            <a:avLst/>
-          </a:prstGeom>
-          <a:noFill/>
-          <a:ln/>
-        </p:spPr>
-        <p:txBody>
-          <a:bodyPr wrap="square" rtlCol="0" anchor="ctr"/>
+          <p:cNvPr id="9" name="Text 6"/>
+          <p:cNvSpPr/>
+          <p:nvPr/>
+        </p:nvSpPr>
+        <p:spPr>
+          <a:xfrm>
+            <a:off x="8092440" y="1737360"/>
+            <a:ext cx="3291840" cy="256032"/>
+          </a:xfrm>
+          <a:prstGeom prst="rect">
+            <a:avLst/>
+          </a:prstGeom>
+          <a:noFill/>
+          <a:ln/>
+        </p:spPr>
+        <p:txBody>
+          <a:bodyPr wrap="square" lIns="0" tIns="0" rIns="0" bIns="0" rtlCol="0" anchor="ctr"/>
           <a:lstStyle/>
           <a:p>
             <a:pPr indent="0" marL="0">
               <a:buNone/>
             </a:pPr>
             <a:r>
-              <a:rPr lang="en-US" sz="1400" b="1" dirty="0">
+              <a:rPr lang="en-US" sz="900" b="1" spc="100" kern="0" dirty="0">
+                <a:solidFill>
+                  <a:srgbClr val="5B6B76"/>
+                </a:solidFill>
+                <a:latin typeface="Calibri" pitchFamily="34" charset="0"/>
+                <a:ea typeface="Calibri" pitchFamily="34" charset="-122"/>
+                <a:cs typeface="Calibri" pitchFamily="34" charset="-120"/>
+              </a:rPr>
+              <a:t>THE FULL-SAMPLE NUMBER</a:t>
+            </a:r>
+            <a:endParaRPr lang="en-US" sz="900" dirty="0"/>
+          </a:p>
+        </p:txBody>
+      </p:sp>
+      <p:sp>
+        <p:nvSpPr>
+          <p:cNvPr id="10" name="Text 7"/>
+          <p:cNvSpPr/>
+          <p:nvPr/>
+        </p:nvSpPr>
+        <p:spPr>
+          <a:xfrm>
+            <a:off x="8092440" y="1993392"/>
+            <a:ext cx="3291840" cy="548640"/>
+          </a:xfrm>
+          <a:prstGeom prst="rect">
+            <a:avLst/>
+          </a:prstGeom>
+          <a:noFill/>
+          <a:ln/>
+        </p:spPr>
+        <p:txBody>
+          <a:bodyPr wrap="square" lIns="0" tIns="0" rIns="0" bIns="0" rtlCol="0" anchor="ctr"/>
+          <a:lstStyle/>
+          <a:p>
+            <a:pPr indent="0" marL="0">
+              <a:buNone/>
+            </a:pPr>
+            <a:r>
+              <a:rPr lang="en-US" sz="3400" b="1" dirty="0">
                 <a:solidFill>
                   <a:srgbClr val="16202A"/>
                 </a:solidFill>
-                <a:latin typeface="Calibri" pitchFamily="34" charset="0"/>
-                <a:ea typeface="Calibri" pitchFamily="34" charset="-122"/>
-                <a:cs typeface="Calibri" pitchFamily="34" charset="-120"/>
-              </a:rPr>
-              <a:t>Rolling Correlation</a:t>
-            </a:r>
-            <a:endParaRPr lang="en-US" sz="1400" dirty="0"/>
-          </a:p>
-        </p:txBody>
-      </p:sp>
-      <p:sp>
-        <p:nvSpPr>
-          <p:cNvPr id="14" name="Text 12"/>
-          <p:cNvSpPr/>
-          <p:nvPr/>
-        </p:nvSpPr>
-        <p:spPr>
-          <a:xfrm>
-            <a:off x="4480560" y="2880360"/>
-            <a:ext cx="6492240" cy="749808"/>
-          </a:xfrm>
-          <a:prstGeom prst="rect">
-            <a:avLst/>
-          </a:prstGeom>
-          <a:noFill/>
-          <a:ln/>
-        </p:spPr>
-        <p:txBody>
-          <a:bodyPr wrap="square" rtlCol="0" anchor="ctr"/>
+                <a:latin typeface="Cambria" pitchFamily="34" charset="0"/>
+                <a:ea typeface="Cambria" pitchFamily="34" charset="-122"/>
+                <a:cs typeface="Cambria" pitchFamily="34" charset="-120"/>
+              </a:rPr>
+              <a:t>+0.07</a:t>
+            </a:r>
+            <a:endParaRPr lang="en-US" sz="3400" dirty="0"/>
+          </a:p>
+        </p:txBody>
+      </p:sp>
+      <p:sp>
+        <p:nvSpPr>
+          <p:cNvPr id="11" name="Text 8"/>
+          <p:cNvSpPr/>
+          <p:nvPr/>
+        </p:nvSpPr>
+        <p:spPr>
+          <a:xfrm>
+            <a:off x="8092440" y="2542032"/>
+            <a:ext cx="3291840" cy="566928"/>
+          </a:xfrm>
+          <a:prstGeom prst="rect">
+            <a:avLst/>
+          </a:prstGeom>
+          <a:noFill/>
+          <a:ln/>
+        </p:spPr>
+        <p:txBody>
+          <a:bodyPr wrap="square" lIns="0" tIns="0" rIns="0" bIns="0" rtlCol="0" anchor="ctr"/>
           <a:lstStyle/>
           <a:p>
             <a:pPr indent="0" marL="0">
@@ -12510,7 +12804,7 @@
               <a:buNone/>
             </a:pPr>
             <a:r>
-              <a:rPr lang="en-US" sz="1200" dirty="0">
+              <a:rPr lang="en-US" sz="1030" dirty="0">
                 <a:solidFill>
                   <a:srgbClr val="5B6B76"/>
                 </a:solidFill>
@@ -12518,339 +12812,202 @@
                 <a:ea typeface="Calibri" pitchFamily="34" charset="-122"/>
                 <a:cs typeface="Calibri" pitchFamily="34" charset="-120"/>
               </a:rPr>
-              <a:t>Recomputed over a moving window — the crypto/equity relationship is regime-dependent and shifts over time, not fixed</a:t>
-            </a:r>
-            <a:endParaRPr lang="en-US" sz="1200" dirty="0"/>
-          </a:p>
-        </p:txBody>
-      </p:sp>
-      <p:sp>
-        <p:nvSpPr>
-          <p:cNvPr id="15" name="Shape 13"/>
-          <p:cNvSpPr/>
-          <p:nvPr/>
-        </p:nvSpPr>
-        <p:spPr>
-          <a:xfrm>
-            <a:off x="548640" y="3886200"/>
-            <a:ext cx="10607040" cy="932688"/>
+              <a:t>BTC to S&amp;P 500 across all 250 days — near zero. On this alone, crypto looks like a perfect diversifier.</a:t>
+            </a:r>
+            <a:endParaRPr lang="en-US" sz="1030" dirty="0"/>
+          </a:p>
+        </p:txBody>
+      </p:sp>
+      <p:sp>
+        <p:nvSpPr>
+          <p:cNvPr id="12" name="Text 9"/>
+          <p:cNvSpPr/>
+          <p:nvPr/>
+        </p:nvSpPr>
+        <p:spPr>
+          <a:xfrm>
+            <a:off x="8092440" y="3255264"/>
+            <a:ext cx="3291840" cy="274320"/>
+          </a:xfrm>
+          <a:prstGeom prst="rect">
+            <a:avLst/>
+          </a:prstGeom>
+          <a:noFill/>
+          <a:ln/>
+        </p:spPr>
+        <p:txBody>
+          <a:bodyPr wrap="square" lIns="0" tIns="0" rIns="0" bIns="0" rtlCol="0" anchor="ctr"/>
+          <a:lstStyle/>
+          <a:p>
+            <a:pPr indent="0" marL="0">
+              <a:buNone/>
+            </a:pPr>
+            <a:r>
+              <a:rPr lang="en-US" sz="1050" b="1" i="1" dirty="0">
+                <a:solidFill>
+                  <a:srgbClr val="0097A7"/>
+                </a:solidFill>
+                <a:latin typeface="Calibri" pitchFamily="34" charset="0"/>
+                <a:ea typeface="Calibri" pitchFamily="34" charset="-122"/>
+                <a:cs typeface="Calibri" pitchFamily="34" charset="-120"/>
+              </a:rPr>
+              <a:t>↓  split the sample</a:t>
+            </a:r>
+            <a:endParaRPr lang="en-US" sz="1050" dirty="0"/>
+          </a:p>
+        </p:txBody>
+      </p:sp>
+      <p:sp>
+        <p:nvSpPr>
+          <p:cNvPr id="13" name="Shape 10"/>
+          <p:cNvSpPr/>
+          <p:nvPr/>
+        </p:nvSpPr>
+        <p:spPr>
+          <a:xfrm>
+            <a:off x="7818120" y="3611880"/>
+            <a:ext cx="3840480" cy="2331720"/>
           </a:xfrm>
           <a:prstGeom prst="roundRect">
             <a:avLst>
-              <a:gd name="adj" fmla="val 7843"/>
+              <a:gd name="adj" fmla="val 3137"/>
             </a:avLst>
           </a:prstGeom>
           <a:solidFill>
-            <a:srgbClr val="F1F5F6"/>
+            <a:srgbClr val="1D2329"/>
           </a:solidFill>
           <a:ln/>
-        </p:spPr>
-      </p:sp>
-      <p:sp>
-        <p:nvSpPr>
-          <p:cNvPr id="16" name="Shape 14"/>
-          <p:cNvSpPr/>
-          <p:nvPr/>
-        </p:nvSpPr>
-        <p:spPr>
-          <a:xfrm>
-            <a:off x="777240" y="4059936"/>
-            <a:ext cx="585216" cy="585216"/>
-          </a:xfrm>
-          <a:prstGeom prst="ellipse">
-            <a:avLst/>
-          </a:prstGeom>
-          <a:solidFill>
-            <a:srgbClr val="00BCD4"/>
-          </a:solidFill>
-          <a:ln/>
-        </p:spPr>
-      </p:sp>
-      <p:sp>
-        <p:nvSpPr>
-          <p:cNvPr id="17" name="Text 15"/>
-          <p:cNvSpPr/>
-          <p:nvPr/>
-        </p:nvSpPr>
-        <p:spPr>
-          <a:xfrm>
-            <a:off x="777240" y="4059936"/>
-            <a:ext cx="585216" cy="585216"/>
-          </a:xfrm>
-          <a:prstGeom prst="rect">
-            <a:avLst/>
-          </a:prstGeom>
-          <a:noFill/>
-          <a:ln/>
-        </p:spPr>
-        <p:txBody>
-          <a:bodyPr wrap="square" rtlCol="0" anchor="ctr"/>
-          <a:lstStyle/>
-          <a:p>
-            <a:pPr algn="ctr" indent="0" marL="0">
-              <a:buNone/>
-            </a:pPr>
-            <a:r>
-              <a:rPr lang="en-US" sz="1600" b="1" dirty="0">
-                <a:solidFill>
-                  <a:srgbClr val="14181C"/>
-                </a:solidFill>
-                <a:latin typeface="Calibri" pitchFamily="34" charset="0"/>
-                <a:ea typeface="Calibri" pitchFamily="34" charset="-122"/>
-                <a:cs typeface="Calibri" pitchFamily="34" charset="-120"/>
-              </a:rPr>
-              <a:t>⇄</a:t>
-            </a:r>
-            <a:endParaRPr lang="en-US" sz="1600" dirty="0"/>
-          </a:p>
-        </p:txBody>
-      </p:sp>
-      <p:sp>
-        <p:nvSpPr>
-          <p:cNvPr id="18" name="Text 16"/>
-          <p:cNvSpPr/>
-          <p:nvPr/>
-        </p:nvSpPr>
-        <p:spPr>
-          <a:xfrm>
-            <a:off x="1600200" y="3977640"/>
-            <a:ext cx="2743200" cy="749808"/>
-          </a:xfrm>
-          <a:prstGeom prst="rect">
-            <a:avLst/>
-          </a:prstGeom>
-          <a:noFill/>
-          <a:ln/>
-        </p:spPr>
-        <p:txBody>
-          <a:bodyPr wrap="square" rtlCol="0" anchor="ctr"/>
+          <a:effectLst>
+            <a:outerShdw sx="100000" sy="100000" kx="0" ky="0" algn="bl" rotWithShape="0" blurRad="101600" dist="38100" dir="5400000">
+              <a:srgbClr val="000000">
+                <a:alpha val="35000"/>
+              </a:srgbClr>
+            </a:outerShdw>
+          </a:effectLst>
+        </p:spPr>
+      </p:sp>
+      <p:sp>
+        <p:nvSpPr>
+          <p:cNvPr id="14" name="Text 11"/>
+          <p:cNvSpPr/>
+          <p:nvPr/>
+        </p:nvSpPr>
+        <p:spPr>
+          <a:xfrm>
+            <a:off x="8092440" y="3794760"/>
+            <a:ext cx="3291840" cy="256032"/>
+          </a:xfrm>
+          <a:prstGeom prst="rect">
+            <a:avLst/>
+          </a:prstGeom>
+          <a:noFill/>
+          <a:ln/>
+        </p:spPr>
+        <p:txBody>
+          <a:bodyPr wrap="square" lIns="0" tIns="0" rIns="0" bIns="0" rtlCol="0" anchor="ctr"/>
           <a:lstStyle/>
           <a:p>
             <a:pPr indent="0" marL="0">
               <a:buNone/>
             </a:pPr>
             <a:r>
-              <a:rPr lang="en-US" sz="1400" b="1" dirty="0">
-                <a:solidFill>
-                  <a:srgbClr val="16202A"/>
-                </a:solidFill>
-                <a:latin typeface="Calibri" pitchFamily="34" charset="0"/>
-                <a:ea typeface="Calibri" pitchFamily="34" charset="-122"/>
-                <a:cs typeface="Calibri" pitchFamily="34" charset="-120"/>
-              </a:rPr>
-              <a:t>Beta</a:t>
-            </a:r>
-            <a:endParaRPr lang="en-US" sz="1400" dirty="0"/>
-          </a:p>
-        </p:txBody>
-      </p:sp>
-      <p:sp>
-        <p:nvSpPr>
-          <p:cNvPr id="19" name="Text 17"/>
-          <p:cNvSpPr/>
-          <p:nvPr/>
-        </p:nvSpPr>
-        <p:spPr>
-          <a:xfrm>
-            <a:off x="4480560" y="3977640"/>
-            <a:ext cx="6492240" cy="749808"/>
-          </a:xfrm>
-          <a:prstGeom prst="rect">
-            <a:avLst/>
-          </a:prstGeom>
-          <a:noFill/>
-          <a:ln/>
-        </p:spPr>
-        <p:txBody>
-          <a:bodyPr wrap="square" rtlCol="0" anchor="ctr"/>
+              <a:rPr lang="en-US" sz="900" b="1" spc="100" kern="0" dirty="0">
+                <a:solidFill>
+                  <a:srgbClr val="00BCD4"/>
+                </a:solidFill>
+                <a:latin typeface="Calibri" pitchFamily="34" charset="0"/>
+                <a:ea typeface="Calibri" pitchFamily="34" charset="-122"/>
+                <a:cs typeface="Calibri" pitchFamily="34" charset="-120"/>
+              </a:rPr>
+              <a:t>WHAT ACTUALLY HAPPENS</a:t>
+            </a:r>
+            <a:endParaRPr lang="en-US" sz="900" dirty="0"/>
+          </a:p>
+        </p:txBody>
+      </p:sp>
+      <p:sp>
+        <p:nvSpPr>
+          <p:cNvPr id="15" name="Text 12"/>
+          <p:cNvSpPr/>
+          <p:nvPr/>
+        </p:nvSpPr>
+        <p:spPr>
+          <a:xfrm>
+            <a:off x="8092440" y="4114800"/>
+            <a:ext cx="3291840" cy="1691640"/>
+          </a:xfrm>
+          <a:prstGeom prst="rect">
+            <a:avLst/>
+          </a:prstGeom>
+          <a:noFill/>
+          <a:ln/>
+        </p:spPr>
+        <p:txBody>
+          <a:bodyPr wrap="square" lIns="0" tIns="0" rIns="0" bIns="0" rtlCol="0" anchor="t"/>
           <a:lstStyle/>
           <a:p>
             <a:pPr indent="0" marL="0">
               <a:lnSpc>
-                <a:spcPct val="120000"/>
+                <a:spcPct val="125000"/>
               </a:lnSpc>
               <a:buNone/>
             </a:pPr>
             <a:r>
-              <a:rPr lang="en-US" sz="1200" dirty="0">
-                <a:solidFill>
-                  <a:srgbClr val="5B6B76"/>
-                </a:solidFill>
-                <a:latin typeface="Calibri" pitchFamily="34" charset="0"/>
-                <a:ea typeface="Calibri" pitchFamily="34" charset="-122"/>
-                <a:cs typeface="Calibri" pitchFamily="34" charset="-120"/>
-              </a:rPr>
-              <a:t>How sharply an asset's returns swing relative to a benchmark like the S&amp;P 500</a:t>
-            </a:r>
-            <a:endParaRPr lang="en-US" sz="1200" dirty="0"/>
-          </a:p>
-        </p:txBody>
-      </p:sp>
-      <p:sp>
-        <p:nvSpPr>
-          <p:cNvPr id="20" name="Shape 18"/>
-          <p:cNvSpPr/>
-          <p:nvPr/>
-        </p:nvSpPr>
-        <p:spPr>
-          <a:xfrm>
-            <a:off x="548640" y="4983480"/>
-            <a:ext cx="10607040" cy="932688"/>
-          </a:xfrm>
-          <a:prstGeom prst="roundRect">
-            <a:avLst>
-              <a:gd name="adj" fmla="val 7843"/>
-            </a:avLst>
-          </a:prstGeom>
-          <a:solidFill>
-            <a:srgbClr val="F1F5F6"/>
-          </a:solidFill>
-          <a:ln/>
-        </p:spPr>
-      </p:sp>
-      <p:sp>
-        <p:nvSpPr>
-          <p:cNvPr id="21" name="Shape 19"/>
-          <p:cNvSpPr/>
-          <p:nvPr/>
-        </p:nvSpPr>
-        <p:spPr>
-          <a:xfrm>
-            <a:off x="777240" y="5157216"/>
-            <a:ext cx="585216" cy="585216"/>
-          </a:xfrm>
-          <a:prstGeom prst="ellipse">
-            <a:avLst/>
-          </a:prstGeom>
-          <a:solidFill>
-            <a:srgbClr val="00BCD4"/>
-          </a:solidFill>
-          <a:ln/>
-        </p:spPr>
-      </p:sp>
-      <p:sp>
-        <p:nvSpPr>
-          <p:cNvPr id="22" name="Text 20"/>
-          <p:cNvSpPr/>
-          <p:nvPr/>
-        </p:nvSpPr>
-        <p:spPr>
-          <a:xfrm>
-            <a:off x="777240" y="5157216"/>
-            <a:ext cx="585216" cy="585216"/>
-          </a:xfrm>
-          <a:prstGeom prst="rect">
-            <a:avLst/>
-          </a:prstGeom>
-          <a:noFill/>
-          <a:ln/>
-        </p:spPr>
-        <p:txBody>
-          <a:bodyPr wrap="square" rtlCol="0" anchor="ctr"/>
-          <a:lstStyle/>
-          <a:p>
-            <a:pPr algn="ctr" indent="0" marL="0">
-              <a:buNone/>
-            </a:pPr>
-            <a:r>
-              <a:rPr lang="en-US" sz="1600" b="1" dirty="0">
-                <a:solidFill>
-                  <a:srgbClr val="14181C"/>
-                </a:solidFill>
-                <a:latin typeface="Calibri" pitchFamily="34" charset="0"/>
-                <a:ea typeface="Calibri" pitchFamily="34" charset="-122"/>
-                <a:cs typeface="Calibri" pitchFamily="34" charset="-120"/>
-              </a:rPr>
-              <a:t>⇄</a:t>
-            </a:r>
-            <a:endParaRPr lang="en-US" sz="1600" dirty="0"/>
-          </a:p>
-        </p:txBody>
-      </p:sp>
-      <p:sp>
-        <p:nvSpPr>
-          <p:cNvPr id="23" name="Text 21"/>
-          <p:cNvSpPr/>
-          <p:nvPr/>
-        </p:nvSpPr>
-        <p:spPr>
-          <a:xfrm>
-            <a:off x="1600200" y="5074920"/>
-            <a:ext cx="2743200" cy="749808"/>
-          </a:xfrm>
-          <a:prstGeom prst="rect">
-            <a:avLst/>
-          </a:prstGeom>
-          <a:noFill/>
-          <a:ln/>
-        </p:spPr>
-        <p:txBody>
-          <a:bodyPr wrap="square" rtlCol="0" anchor="ctr"/>
-          <a:lstStyle/>
-          <a:p>
-            <a:pPr indent="0" marL="0">
-              <a:buNone/>
-            </a:pPr>
-            <a:r>
-              <a:rPr lang="en-US" sz="1400" b="1" dirty="0">
-                <a:solidFill>
-                  <a:srgbClr val="16202A"/>
-                </a:solidFill>
-                <a:latin typeface="Calibri" pitchFamily="34" charset="0"/>
-                <a:ea typeface="Calibri" pitchFamily="34" charset="-122"/>
-                <a:cs typeface="Calibri" pitchFamily="34" charset="-120"/>
-              </a:rPr>
-              <a:t>Regime Correlation</a:t>
-            </a:r>
-            <a:endParaRPr lang="en-US" sz="1400" dirty="0"/>
-          </a:p>
-        </p:txBody>
-      </p:sp>
-      <p:sp>
-        <p:nvSpPr>
-          <p:cNvPr id="24" name="Text 22"/>
-          <p:cNvSpPr/>
-          <p:nvPr/>
-        </p:nvSpPr>
-        <p:spPr>
-          <a:xfrm>
-            <a:off x="4480560" y="5074920"/>
-            <a:ext cx="6492240" cy="749808"/>
-          </a:xfrm>
-          <a:prstGeom prst="rect">
-            <a:avLst/>
-          </a:prstGeom>
-          <a:noFill/>
-          <a:ln/>
-        </p:spPr>
-        <p:txBody>
-          <a:bodyPr wrap="square" rtlCol="0" anchor="ctr"/>
-          <a:lstStyle/>
+              <a:rPr lang="en-US" sz="1300" b="1" dirty="0">
+                <a:solidFill>
+                  <a:srgbClr val="F5F9FA"/>
+                </a:solidFill>
+                <a:latin typeface="Calibri" pitchFamily="34" charset="0"/>
+                <a:ea typeface="Calibri" pitchFamily="34" charset="-122"/>
+                <a:cs typeface="Calibri" pitchFamily="34" charset="-120"/>
+              </a:rPr>
+              <a:t>The diversification is real when you don't need it, and weakens exactly when you do.</a:t>
+            </a:r>
+            <a:endParaRPr lang="en-US" sz="1300" dirty="0"/>
+          </a:p>
           <a:p>
             <a:pPr indent="0" marL="0">
               <a:lnSpc>
-                <a:spcPct val="120000"/>
+                <a:spcPct val="125000"/>
               </a:lnSpc>
               <a:buNone/>
             </a:pPr>
             <a:r>
-              <a:rPr lang="en-US" sz="1200" dirty="0">
-                <a:solidFill>
-                  <a:srgbClr val="5B6B76"/>
-                </a:solidFill>
-                <a:latin typeface="Calibri" pitchFamily="34" charset="0"/>
-                <a:ea typeface="Calibri" pitchFamily="34" charset="-122"/>
-                <a:cs typeface="Calibri" pitchFamily="34" charset="-120"/>
-              </a:rPr>
-              <a:t>Correlation measured separately in calm markets vs. the benchmark's worst days — does crypto de-correlate exactly when it matters, or converge?</a:t>
-            </a:r>
-            <a:endParaRPr lang="en-US" sz="1200" dirty="0"/>
-          </a:p>
-        </p:txBody>
-      </p:sp>
-      <p:sp>
-        <p:nvSpPr>
-          <p:cNvPr id="25" name="Text 23"/>
+              <a:rPr lang="en-US" sz="500" dirty="0">
+                <a:solidFill>
+                  <a:srgbClr val="000000"/>
+                </a:solidFill>
+              </a:rPr>
+              <a:t>
+</a:t>
+            </a:r>
+            <a:endParaRPr lang="en-US" sz="1300" dirty="0"/>
+          </a:p>
+          <a:p>
+            <a:pPr indent="0" marL="0">
+              <a:lnSpc>
+                <a:spcPct val="125000"/>
+              </a:lnSpc>
+              <a:buNone/>
+            </a:pPr>
+            <a:r>
+              <a:rPr lang="en-US" sz="1100" dirty="0">
+                <a:solidFill>
+                  <a:srgbClr val="9FB0B8"/>
+                </a:solidFill>
+                <a:latin typeface="Calibri" pitchFamily="34" charset="0"/>
+                <a:ea typeface="Calibri" pitchFamily="34" charset="-122"/>
+                <a:cs typeface="Calibri" pitchFamily="34" charset="-120"/>
+              </a:rPr>
+              <a:t>ADA moves furthest — +0.10 to +0.32. A single full-window figure hides all of it.</a:t>
+            </a:r>
+            <a:endParaRPr lang="en-US" sz="1300" dirty="0"/>
+          </a:p>
+        </p:txBody>
+      </p:sp>
+      <p:sp>
+        <p:nvSpPr>
+          <p:cNvPr id="16" name="Text 13"/>
           <p:cNvSpPr/>
           <p:nvPr/>
         </p:nvSpPr>
@@ -12889,7 +13046,7 @@
       </p:sp>
       <p:sp>
         <p:nvSpPr>
-          <p:cNvPr id="26" name="Text 24"/>
+          <p:cNvPr id="17" name="Text 14"/>
           <p:cNvSpPr/>
           <p:nvPr/>
         </p:nvSpPr>
@@ -15221,33 +15378,1128 @@
           </a:p>
         </p:txBody>
       </p:sp>
-      <p:pic>
-        <p:nvPicPr>
-          <p:cNvPr id="5" name="Image 0" descr="C:\Users\garim\AppData\Local\Temp\pptxwork\assets\pipeline.png">    </p:cNvPr>
-          <p:cNvPicPr>
-            <a:picLocks noChangeAspect="1"/>
-          </p:cNvPicPr>
-          <p:nvPr/>
-        </p:nvPicPr>
-        <p:blipFill>
-          <a:blip r:embed="rId1"/>
-          <a:stretch>
-            <a:fillRect/>
-          </a:stretch>
-        </p:blipFill>
-        <p:spPr>
-          <a:xfrm>
-            <a:off x="1966839" y="1600200"/>
-            <a:ext cx="8258016" cy="4709160"/>
-          </a:xfrm>
-          <a:prstGeom prst="rect">
-            <a:avLst/>
-          </a:prstGeom>
-        </p:spPr>
-      </p:pic>
-      <p:sp>
-        <p:nvSpPr>
-          <p:cNvPr id="6" name="Text 3"/>
+      <p:sp>
+        <p:nvSpPr>
+          <p:cNvPr id="5" name="Shape 3"/>
+          <p:cNvSpPr/>
+          <p:nvPr/>
+        </p:nvSpPr>
+        <p:spPr>
+          <a:xfrm>
+            <a:off x="548640" y="2560320"/>
+            <a:ext cx="1965960" cy="2286000"/>
+          </a:xfrm>
+          <a:prstGeom prst="roundRect">
+            <a:avLst>
+              <a:gd name="adj" fmla="val 3721"/>
+            </a:avLst>
+          </a:prstGeom>
+          <a:solidFill>
+            <a:srgbClr val="F1F5F6"/>
+          </a:solidFill>
+          <a:ln w="15875">
+            <a:solidFill>
+              <a:srgbClr val="DCE4E6"/>
+            </a:solidFill>
+            <a:prstDash val="solid"/>
+          </a:ln>
+          <a:effectLst>
+            <a:outerShdw sx="100000" sy="100000" kx="0" ky="0" algn="bl" rotWithShape="0" blurRad="101600" dist="38100" dir="5400000">
+              <a:srgbClr val="000000">
+                <a:alpha val="10000"/>
+              </a:srgbClr>
+            </a:outerShdw>
+          </a:effectLst>
+        </p:spPr>
+      </p:sp>
+      <p:sp>
+        <p:nvSpPr>
+          <p:cNvPr id="6" name="Text 4"/>
+          <p:cNvSpPr/>
+          <p:nvPr/>
+        </p:nvSpPr>
+        <p:spPr>
+          <a:xfrm>
+            <a:off x="685800" y="2724912"/>
+            <a:ext cx="1691640" cy="411480"/>
+          </a:xfrm>
+          <a:prstGeom prst="rect">
+            <a:avLst/>
+          </a:prstGeom>
+          <a:noFill/>
+          <a:ln/>
+        </p:spPr>
+        <p:txBody>
+          <a:bodyPr wrap="square" lIns="0" tIns="0" rIns="0" bIns="0" rtlCol="0" anchor="ctr"/>
+          <a:lstStyle/>
+          <a:p>
+            <a:pPr algn="ctr" indent="0" marL="0">
+              <a:buNone/>
+            </a:pPr>
+            <a:r>
+              <a:rPr lang="en-US" sz="1250" b="1" dirty="0">
+                <a:solidFill>
+                  <a:srgbClr val="16202A"/>
+                </a:solidFill>
+                <a:latin typeface="Calibri" pitchFamily="34" charset="0"/>
+                <a:ea typeface="Calibri" pitchFamily="34" charset="-122"/>
+                <a:cs typeface="Calibri" pitchFamily="34" charset="-120"/>
+              </a:rPr>
+              <a:t>External APIs</a:t>
+            </a:r>
+            <a:endParaRPr lang="en-US" sz="1250" dirty="0"/>
+          </a:p>
+        </p:txBody>
+      </p:sp>
+      <p:sp>
+        <p:nvSpPr>
+          <p:cNvPr id="7" name="Text 5"/>
+          <p:cNvSpPr/>
+          <p:nvPr/>
+        </p:nvSpPr>
+        <p:spPr>
+          <a:xfrm>
+            <a:off x="685800" y="3127248"/>
+            <a:ext cx="1691640" cy="1572768"/>
+          </a:xfrm>
+          <a:prstGeom prst="rect">
+            <a:avLst/>
+          </a:prstGeom>
+          <a:noFill/>
+          <a:ln/>
+        </p:spPr>
+        <p:txBody>
+          <a:bodyPr wrap="square" lIns="0" tIns="0" rIns="0" bIns="0" rtlCol="0" anchor="ctr"/>
+          <a:lstStyle/>
+          <a:p>
+            <a:pPr algn="ctr" indent="0" marL="0">
+              <a:lnSpc>
+                <a:spcPct val="122000"/>
+              </a:lnSpc>
+              <a:buNone/>
+            </a:pPr>
+            <a:r>
+              <a:rPr lang="en-US" sz="960" dirty="0">
+                <a:solidFill>
+                  <a:srgbClr val="5B6B76"/>
+                </a:solidFill>
+                <a:latin typeface="Calibri" pitchFamily="34" charset="0"/>
+                <a:ea typeface="Calibri" pitchFamily="34" charset="-122"/>
+                <a:cs typeface="Calibri" pitchFamily="34" charset="-120"/>
+              </a:rPr>
+              <a:t>CoinGecko</a:t>
+            </a:r>
+            <a:endParaRPr lang="en-US" sz="960" dirty="0"/>
+          </a:p>
+          <a:p>
+            <a:pPr algn="ctr" indent="0" marL="0">
+              <a:lnSpc>
+                <a:spcPct val="122000"/>
+              </a:lnSpc>
+              <a:buNone/>
+            </a:pPr>
+            <a:r>
+              <a:rPr lang="en-US" sz="960" dirty="0">
+                <a:solidFill>
+                  <a:srgbClr val="5B6B76"/>
+                </a:solidFill>
+                <a:latin typeface="Calibri" pitchFamily="34" charset="0"/>
+                <a:ea typeface="Calibri" pitchFamily="34" charset="-122"/>
+                <a:cs typeface="Calibri" pitchFamily="34" charset="-120"/>
+              </a:rPr>
+              <a:t>Yahoo Finance</a:t>
+            </a:r>
+            <a:endParaRPr lang="en-US" sz="960" dirty="0"/>
+          </a:p>
+          <a:p>
+            <a:pPr algn="ctr" indent="0" marL="0">
+              <a:lnSpc>
+                <a:spcPct val="122000"/>
+              </a:lnSpc>
+              <a:buNone/>
+            </a:pPr>
+            <a:r>
+              <a:rPr lang="en-US" sz="960" dirty="0">
+                <a:solidFill>
+                  <a:srgbClr val="5B6B76"/>
+                </a:solidFill>
+                <a:latin typeface="Calibri" pitchFamily="34" charset="0"/>
+                <a:ea typeface="Calibri" pitchFamily="34" charset="-122"/>
+                <a:cs typeface="Calibri" pitchFamily="34" charset="-120"/>
+              </a:rPr>
+              <a:t>Fear &amp; Greed</a:t>
+            </a:r>
+            <a:endParaRPr lang="en-US" sz="960" dirty="0"/>
+          </a:p>
+          <a:p>
+            <a:pPr algn="ctr" indent="0" marL="0">
+              <a:lnSpc>
+                <a:spcPct val="122000"/>
+              </a:lnSpc>
+              <a:buNone/>
+            </a:pPr>
+            <a:r>
+              <a:rPr lang="en-US" sz="960" dirty="0">
+                <a:solidFill>
+                  <a:srgbClr val="5B6B76"/>
+                </a:solidFill>
+                <a:latin typeface="Calibri" pitchFamily="34" charset="0"/>
+                <a:ea typeface="Calibri" pitchFamily="34" charset="-122"/>
+                <a:cs typeface="Calibri" pitchFamily="34" charset="-120"/>
+              </a:rPr>
+              <a:t>Blockchain.info</a:t>
+            </a:r>
+            <a:endParaRPr lang="en-US" sz="960" dirty="0"/>
+          </a:p>
+        </p:txBody>
+      </p:sp>
+      <p:sp>
+        <p:nvSpPr>
+          <p:cNvPr id="8" name="Shape 6"/>
+          <p:cNvSpPr/>
+          <p:nvPr/>
+        </p:nvSpPr>
+        <p:spPr>
+          <a:xfrm>
+            <a:off x="2834640" y="2560320"/>
+            <a:ext cx="1965960" cy="2286000"/>
+          </a:xfrm>
+          <a:prstGeom prst="roundRect">
+            <a:avLst>
+              <a:gd name="adj" fmla="val 3721"/>
+            </a:avLst>
+          </a:prstGeom>
+          <a:solidFill>
+            <a:srgbClr val="14181C"/>
+          </a:solidFill>
+          <a:ln/>
+          <a:effectLst>
+            <a:outerShdw sx="100000" sy="100000" kx="0" ky="0" algn="bl" rotWithShape="0" blurRad="101600" dist="38100" dir="5400000">
+              <a:srgbClr val="000000">
+                <a:alpha val="28000"/>
+              </a:srgbClr>
+            </a:outerShdw>
+          </a:effectLst>
+        </p:spPr>
+      </p:sp>
+      <p:sp>
+        <p:nvSpPr>
+          <p:cNvPr id="9" name="Text 7"/>
+          <p:cNvSpPr/>
+          <p:nvPr/>
+        </p:nvSpPr>
+        <p:spPr>
+          <a:xfrm>
+            <a:off x="2971800" y="2724912"/>
+            <a:ext cx="1691640" cy="411480"/>
+          </a:xfrm>
+          <a:prstGeom prst="rect">
+            <a:avLst/>
+          </a:prstGeom>
+          <a:noFill/>
+          <a:ln/>
+        </p:spPr>
+        <p:txBody>
+          <a:bodyPr wrap="square" lIns="0" tIns="0" rIns="0" bIns="0" rtlCol="0" anchor="ctr"/>
+          <a:lstStyle/>
+          <a:p>
+            <a:pPr algn="ctr" indent="0" marL="0">
+              <a:buNone/>
+            </a:pPr>
+            <a:r>
+              <a:rPr lang="en-US" sz="1250" b="1" dirty="0">
+                <a:solidFill>
+                  <a:srgbClr val="F5F9FA"/>
+                </a:solidFill>
+                <a:latin typeface="Calibri" pitchFamily="34" charset="0"/>
+                <a:ea typeface="Calibri" pitchFamily="34" charset="-122"/>
+                <a:cs typeface="Calibri" pitchFamily="34" charset="-120"/>
+              </a:rPr>
+              <a:t>Ingestion</a:t>
+            </a:r>
+            <a:endParaRPr lang="en-US" sz="1250" dirty="0"/>
+          </a:p>
+        </p:txBody>
+      </p:sp>
+      <p:sp>
+        <p:nvSpPr>
+          <p:cNvPr id="10" name="Text 8"/>
+          <p:cNvSpPr/>
+          <p:nvPr/>
+        </p:nvSpPr>
+        <p:spPr>
+          <a:xfrm>
+            <a:off x="2971800" y="3127248"/>
+            <a:ext cx="1691640" cy="1572768"/>
+          </a:xfrm>
+          <a:prstGeom prst="rect">
+            <a:avLst/>
+          </a:prstGeom>
+          <a:noFill/>
+          <a:ln/>
+        </p:spPr>
+        <p:txBody>
+          <a:bodyPr wrap="square" lIns="0" tIns="0" rIns="0" bIns="0" rtlCol="0" anchor="ctr"/>
+          <a:lstStyle/>
+          <a:p>
+            <a:pPr algn="ctr" indent="0" marL="0">
+              <a:lnSpc>
+                <a:spcPct val="122000"/>
+              </a:lnSpc>
+              <a:buNone/>
+            </a:pPr>
+            <a:r>
+              <a:rPr lang="en-US" sz="960" dirty="0">
+                <a:solidFill>
+                  <a:srgbClr val="9FB0B8"/>
+                </a:solidFill>
+                <a:latin typeface="Calibri" pitchFamily="34" charset="0"/>
+                <a:ea typeface="Calibri" pitchFamily="34" charset="-122"/>
+                <a:cs typeface="Calibri" pitchFamily="34" charset="-120"/>
+              </a:rPr>
+              <a:t>throttle + retry</a:t>
+            </a:r>
+            <a:endParaRPr lang="en-US" sz="960" dirty="0"/>
+          </a:p>
+          <a:p>
+            <a:pPr algn="ctr" indent="0" marL="0">
+              <a:lnSpc>
+                <a:spcPct val="122000"/>
+              </a:lnSpc>
+              <a:buNone/>
+            </a:pPr>
+            <a:r>
+              <a:rPr lang="en-US" sz="960" dirty="0">
+                <a:solidFill>
+                  <a:srgbClr val="9FB0B8"/>
+                </a:solidFill>
+                <a:latin typeface="Calibri" pitchFamily="34" charset="0"/>
+                <a:ea typeface="Calibri" pitchFamily="34" charset="-122"/>
+                <a:cs typeface="Calibri" pitchFamily="34" charset="-120"/>
+              </a:rPr>
+              <a:t>6-hour disk cache</a:t>
+            </a:r>
+            <a:endParaRPr lang="en-US" sz="960" dirty="0"/>
+          </a:p>
+          <a:p>
+            <a:pPr algn="ctr" indent="0" marL="0">
+              <a:lnSpc>
+                <a:spcPct val="122000"/>
+              </a:lnSpc>
+              <a:buNone/>
+            </a:pPr>
+            <a:r>
+              <a:rPr lang="en-US" sz="960" dirty="0">
+                <a:solidFill>
+                  <a:srgbClr val="9FB0B8"/>
+                </a:solidFill>
+                <a:latin typeface="Calibri" pitchFamily="34" charset="0"/>
+                <a:ea typeface="Calibri" pitchFamily="34" charset="-122"/>
+                <a:cs typeface="Calibri" pitchFamily="34" charset="-120"/>
+              </a:rPr>
+              <a:t>synthetic fallback</a:t>
+            </a:r>
+            <a:endParaRPr lang="en-US" sz="960" dirty="0"/>
+          </a:p>
+          <a:p>
+            <a:pPr algn="ctr" indent="0" marL="0">
+              <a:lnSpc>
+                <a:spcPct val="122000"/>
+              </a:lnSpc>
+              <a:buNone/>
+            </a:pPr>
+            <a:r>
+              <a:rPr lang="en-US" sz="960" dirty="0">
+                <a:solidFill>
+                  <a:srgbClr val="9FB0B8"/>
+                </a:solidFill>
+                <a:latin typeface="Calibri" pitchFamily="34" charset="0"/>
+                <a:ea typeface="Calibri" pitchFamily="34" charset="-122"/>
+                <a:cs typeface="Calibri" pitchFamily="34" charset="-120"/>
+              </a:rPr>
+              <a:t>on any failure</a:t>
+            </a:r>
+            <a:endParaRPr lang="en-US" sz="960" dirty="0"/>
+          </a:p>
+        </p:txBody>
+      </p:sp>
+      <p:sp>
+        <p:nvSpPr>
+          <p:cNvPr id="11" name="Shape 9"/>
+          <p:cNvSpPr/>
+          <p:nvPr/>
+        </p:nvSpPr>
+        <p:spPr>
+          <a:xfrm>
+            <a:off x="5120640" y="2560320"/>
+            <a:ext cx="1965960" cy="2286000"/>
+          </a:xfrm>
+          <a:prstGeom prst="roundRect">
+            <a:avLst>
+              <a:gd name="adj" fmla="val 3721"/>
+            </a:avLst>
+          </a:prstGeom>
+          <a:solidFill>
+            <a:srgbClr val="00BCD4"/>
+          </a:solidFill>
+          <a:ln/>
+          <a:effectLst>
+            <a:outerShdw sx="100000" sy="100000" kx="0" ky="0" algn="bl" rotWithShape="0" blurRad="101600" dist="38100" dir="5400000">
+              <a:srgbClr val="000000">
+                <a:alpha val="28000"/>
+              </a:srgbClr>
+            </a:outerShdw>
+          </a:effectLst>
+        </p:spPr>
+      </p:sp>
+      <p:sp>
+        <p:nvSpPr>
+          <p:cNvPr id="12" name="Text 10"/>
+          <p:cNvSpPr/>
+          <p:nvPr/>
+        </p:nvSpPr>
+        <p:spPr>
+          <a:xfrm>
+            <a:off x="5257800" y="2724912"/>
+            <a:ext cx="1691640" cy="411480"/>
+          </a:xfrm>
+          <a:prstGeom prst="rect">
+            <a:avLst/>
+          </a:prstGeom>
+          <a:noFill/>
+          <a:ln/>
+        </p:spPr>
+        <p:txBody>
+          <a:bodyPr wrap="square" lIns="0" tIns="0" rIns="0" bIns="0" rtlCol="0" anchor="ctr"/>
+          <a:lstStyle/>
+          <a:p>
+            <a:pPr algn="ctr" indent="0" marL="0">
+              <a:buNone/>
+            </a:pPr>
+            <a:r>
+              <a:rPr lang="en-US" sz="1250" b="1" dirty="0">
+                <a:solidFill>
+                  <a:srgbClr val="14181C"/>
+                </a:solidFill>
+                <a:latin typeface="Calibri" pitchFamily="34" charset="0"/>
+                <a:ea typeface="Calibri" pitchFamily="34" charset="-122"/>
+                <a:cs typeface="Calibri" pitchFamily="34" charset="-120"/>
+              </a:rPr>
+              <a:t>MarketData</a:t>
+            </a:r>
+            <a:endParaRPr lang="en-US" sz="1250" dirty="0"/>
+          </a:p>
+        </p:txBody>
+      </p:sp>
+      <p:sp>
+        <p:nvSpPr>
+          <p:cNvPr id="13" name="Text 11"/>
+          <p:cNvSpPr/>
+          <p:nvPr/>
+        </p:nvSpPr>
+        <p:spPr>
+          <a:xfrm>
+            <a:off x="5257800" y="3127248"/>
+            <a:ext cx="1691640" cy="1572768"/>
+          </a:xfrm>
+          <a:prstGeom prst="rect">
+            <a:avLst/>
+          </a:prstGeom>
+          <a:noFill/>
+          <a:ln/>
+        </p:spPr>
+        <p:txBody>
+          <a:bodyPr wrap="square" lIns="0" tIns="0" rIns="0" bIns="0" rtlCol="0" anchor="ctr"/>
+          <a:lstStyle/>
+          <a:p>
+            <a:pPr algn="ctr" indent="0" marL="0">
+              <a:lnSpc>
+                <a:spcPct val="122000"/>
+              </a:lnSpc>
+              <a:buNone/>
+            </a:pPr>
+            <a:r>
+              <a:rPr lang="en-US" sz="960" dirty="0">
+                <a:solidFill>
+                  <a:srgbClr val="0D3B3F"/>
+                </a:solidFill>
+                <a:latin typeface="Calibri" pitchFamily="34" charset="0"/>
+                <a:ea typeface="Calibri" pitchFamily="34" charset="-122"/>
+                <a:cs typeface="Calibri" pitchFamily="34" charset="-120"/>
+              </a:rPr>
+              <a:t>one bundle:</a:t>
+            </a:r>
+            <a:endParaRPr lang="en-US" sz="960" dirty="0"/>
+          </a:p>
+          <a:p>
+            <a:pPr algn="ctr" indent="0" marL="0">
+              <a:lnSpc>
+                <a:spcPct val="122000"/>
+              </a:lnSpc>
+              <a:buNone/>
+            </a:pPr>
+            <a:r>
+              <a:rPr lang="en-US" sz="960" dirty="0">
+                <a:solidFill>
+                  <a:srgbClr val="0D3B3F"/>
+                </a:solidFill>
+                <a:latin typeface="Calibri" pitchFamily="34" charset="0"/>
+                <a:ea typeface="Calibri" pitchFamily="34" charset="-122"/>
+                <a:cs typeface="Calibri" pitchFamily="34" charset="-120"/>
+              </a:rPr>
+              <a:t>prices · macro</a:t>
+            </a:r>
+            <a:endParaRPr lang="en-US" sz="960" dirty="0"/>
+          </a:p>
+          <a:p>
+            <a:pPr algn="ctr" indent="0" marL="0">
+              <a:lnSpc>
+                <a:spcPct val="122000"/>
+              </a:lnSpc>
+              <a:buNone/>
+            </a:pPr>
+            <a:r>
+              <a:rPr lang="en-US" sz="960" dirty="0">
+                <a:solidFill>
+                  <a:srgbClr val="0D3B3F"/>
+                </a:solidFill>
+                <a:latin typeface="Calibri" pitchFamily="34" charset="0"/>
+                <a:ea typeface="Calibri" pitchFamily="34" charset="-122"/>
+                <a:cs typeface="Calibri" pitchFamily="34" charset="-120"/>
+              </a:rPr>
+              <a:t>sentiment · on-chain</a:t>
+            </a:r>
+            <a:endParaRPr lang="en-US" sz="960" dirty="0"/>
+          </a:p>
+          <a:p>
+            <a:pPr algn="ctr" indent="0" marL="0">
+              <a:lnSpc>
+                <a:spcPct val="122000"/>
+              </a:lnSpc>
+              <a:buNone/>
+            </a:pPr>
+            <a:r>
+              <a:rPr lang="en-US" sz="960" dirty="0">
+                <a:solidFill>
+                  <a:srgbClr val="0D3B3F"/>
+                </a:solidFill>
+                <a:latin typeface="Calibri" pitchFamily="34" charset="0"/>
+                <a:ea typeface="Calibri" pitchFamily="34" charset="-122"/>
+                <a:cs typeface="Calibri" pitchFamily="34" charset="-120"/>
+              </a:rPr>
+              <a:t>+ per-feed status</a:t>
+            </a:r>
+            <a:endParaRPr lang="en-US" sz="960" dirty="0"/>
+          </a:p>
+        </p:txBody>
+      </p:sp>
+      <p:sp>
+        <p:nvSpPr>
+          <p:cNvPr id="14" name="Shape 12"/>
+          <p:cNvSpPr/>
+          <p:nvPr/>
+        </p:nvSpPr>
+        <p:spPr>
+          <a:xfrm>
+            <a:off x="7406640" y="2153412"/>
+            <a:ext cx="1965960" cy="658368"/>
+          </a:xfrm>
+          <a:prstGeom prst="roundRect">
+            <a:avLst>
+              <a:gd name="adj" fmla="val 9722"/>
+            </a:avLst>
+          </a:prstGeom>
+          <a:solidFill>
+            <a:srgbClr val="14181C"/>
+          </a:solidFill>
+          <a:ln/>
+          <a:effectLst>
+            <a:outerShdw sx="100000" sy="100000" kx="0" ky="0" algn="bl" rotWithShape="0" blurRad="76200" dist="25400" dir="5400000">
+              <a:srgbClr val="000000">
+                <a:alpha val="22000"/>
+              </a:srgbClr>
+            </a:outerShdw>
+          </a:effectLst>
+        </p:spPr>
+      </p:sp>
+      <p:sp>
+        <p:nvSpPr>
+          <p:cNvPr id="15" name="Text 13"/>
+          <p:cNvSpPr/>
+          <p:nvPr/>
+        </p:nvSpPr>
+        <p:spPr>
+          <a:xfrm>
+            <a:off x="7498080" y="2153412"/>
+            <a:ext cx="1783080" cy="658368"/>
+          </a:xfrm>
+          <a:prstGeom prst="rect">
+            <a:avLst/>
+          </a:prstGeom>
+          <a:noFill/>
+          <a:ln/>
+        </p:spPr>
+        <p:txBody>
+          <a:bodyPr wrap="square" lIns="0" tIns="0" rIns="0" bIns="0" rtlCol="0" anchor="ctr"/>
+          <a:lstStyle/>
+          <a:p>
+            <a:pPr algn="ctr" indent="0" marL="0">
+              <a:buNone/>
+            </a:pPr>
+            <a:r>
+              <a:rPr lang="en-US" sz="1100" b="1" dirty="0">
+                <a:solidFill>
+                  <a:srgbClr val="F5F9FA"/>
+                </a:solidFill>
+                <a:latin typeface="Calibri" pitchFamily="34" charset="0"/>
+                <a:ea typeface="Calibri" pitchFamily="34" charset="-122"/>
+                <a:cs typeface="Calibri" pitchFamily="34" charset="-120"/>
+              </a:rPr>
+              <a:t>Volatility &amp; Risk</a:t>
+            </a:r>
+            <a:endParaRPr lang="en-US" sz="1100" dirty="0"/>
+          </a:p>
+        </p:txBody>
+      </p:sp>
+      <p:sp>
+        <p:nvSpPr>
+          <p:cNvPr id="16" name="Shape 14"/>
+          <p:cNvSpPr/>
+          <p:nvPr/>
+        </p:nvSpPr>
+        <p:spPr>
+          <a:xfrm>
+            <a:off x="7406640" y="2967228"/>
+            <a:ext cx="1965960" cy="658368"/>
+          </a:xfrm>
+          <a:prstGeom prst="roundRect">
+            <a:avLst>
+              <a:gd name="adj" fmla="val 9722"/>
+            </a:avLst>
+          </a:prstGeom>
+          <a:solidFill>
+            <a:srgbClr val="14181C"/>
+          </a:solidFill>
+          <a:ln/>
+          <a:effectLst>
+            <a:outerShdw sx="100000" sy="100000" kx="0" ky="0" algn="bl" rotWithShape="0" blurRad="76200" dist="25400" dir="5400000">
+              <a:srgbClr val="000000">
+                <a:alpha val="22000"/>
+              </a:srgbClr>
+            </a:outerShdw>
+          </a:effectLst>
+        </p:spPr>
+      </p:sp>
+      <p:sp>
+        <p:nvSpPr>
+          <p:cNvPr id="17" name="Text 15"/>
+          <p:cNvSpPr/>
+          <p:nvPr/>
+        </p:nvSpPr>
+        <p:spPr>
+          <a:xfrm>
+            <a:off x="7498080" y="2967228"/>
+            <a:ext cx="1783080" cy="658368"/>
+          </a:xfrm>
+          <a:prstGeom prst="rect">
+            <a:avLst/>
+          </a:prstGeom>
+          <a:noFill/>
+          <a:ln/>
+        </p:spPr>
+        <p:txBody>
+          <a:bodyPr wrap="square" lIns="0" tIns="0" rIns="0" bIns="0" rtlCol="0" anchor="ctr"/>
+          <a:lstStyle/>
+          <a:p>
+            <a:pPr algn="ctr" indent="0" marL="0">
+              <a:buNone/>
+            </a:pPr>
+            <a:r>
+              <a:rPr lang="en-US" sz="1100" b="1" dirty="0">
+                <a:solidFill>
+                  <a:srgbClr val="F5F9FA"/>
+                </a:solidFill>
+                <a:latin typeface="Calibri" pitchFamily="34" charset="0"/>
+                <a:ea typeface="Calibri" pitchFamily="34" charset="-122"/>
+                <a:cs typeface="Calibri" pitchFamily="34" charset="-120"/>
+              </a:rPr>
+              <a:t>Market Cycles</a:t>
+            </a:r>
+            <a:endParaRPr lang="en-US" sz="1100" dirty="0"/>
+          </a:p>
+        </p:txBody>
+      </p:sp>
+      <p:sp>
+        <p:nvSpPr>
+          <p:cNvPr id="18" name="Shape 16"/>
+          <p:cNvSpPr/>
+          <p:nvPr/>
+        </p:nvSpPr>
+        <p:spPr>
+          <a:xfrm>
+            <a:off x="7406640" y="3781044"/>
+            <a:ext cx="1965960" cy="658368"/>
+          </a:xfrm>
+          <a:prstGeom prst="roundRect">
+            <a:avLst>
+              <a:gd name="adj" fmla="val 9722"/>
+            </a:avLst>
+          </a:prstGeom>
+          <a:solidFill>
+            <a:srgbClr val="14181C"/>
+          </a:solidFill>
+          <a:ln/>
+          <a:effectLst>
+            <a:outerShdw sx="100000" sy="100000" kx="0" ky="0" algn="bl" rotWithShape="0" blurRad="76200" dist="25400" dir="5400000">
+              <a:srgbClr val="000000">
+                <a:alpha val="22000"/>
+              </a:srgbClr>
+            </a:outerShdw>
+          </a:effectLst>
+        </p:spPr>
+      </p:sp>
+      <p:sp>
+        <p:nvSpPr>
+          <p:cNvPr id="19" name="Text 17"/>
+          <p:cNvSpPr/>
+          <p:nvPr/>
+        </p:nvSpPr>
+        <p:spPr>
+          <a:xfrm>
+            <a:off x="7498080" y="3781044"/>
+            <a:ext cx="1783080" cy="658368"/>
+          </a:xfrm>
+          <a:prstGeom prst="rect">
+            <a:avLst/>
+          </a:prstGeom>
+          <a:noFill/>
+          <a:ln/>
+        </p:spPr>
+        <p:txBody>
+          <a:bodyPr wrap="square" lIns="0" tIns="0" rIns="0" bIns="0" rtlCol="0" anchor="ctr"/>
+          <a:lstStyle/>
+          <a:p>
+            <a:pPr algn="ctr" indent="0" marL="0">
+              <a:buNone/>
+            </a:pPr>
+            <a:r>
+              <a:rPr lang="en-US" sz="1100" b="1" dirty="0">
+                <a:solidFill>
+                  <a:srgbClr val="F5F9FA"/>
+                </a:solidFill>
+                <a:latin typeface="Calibri" pitchFamily="34" charset="0"/>
+                <a:ea typeface="Calibri" pitchFamily="34" charset="-122"/>
+                <a:cs typeface="Calibri" pitchFamily="34" charset="-120"/>
+              </a:rPr>
+              <a:t>Correlation</a:t>
+            </a:r>
+            <a:endParaRPr lang="en-US" sz="1100" dirty="0"/>
+          </a:p>
+        </p:txBody>
+      </p:sp>
+      <p:sp>
+        <p:nvSpPr>
+          <p:cNvPr id="20" name="Shape 18"/>
+          <p:cNvSpPr/>
+          <p:nvPr/>
+        </p:nvSpPr>
+        <p:spPr>
+          <a:xfrm>
+            <a:off x="7406640" y="4594860"/>
+            <a:ext cx="1965960" cy="658368"/>
+          </a:xfrm>
+          <a:prstGeom prst="roundRect">
+            <a:avLst>
+              <a:gd name="adj" fmla="val 9722"/>
+            </a:avLst>
+          </a:prstGeom>
+          <a:solidFill>
+            <a:srgbClr val="14181C"/>
+          </a:solidFill>
+          <a:ln/>
+          <a:effectLst>
+            <a:outerShdw sx="100000" sy="100000" kx="0" ky="0" algn="bl" rotWithShape="0" blurRad="76200" dist="25400" dir="5400000">
+              <a:srgbClr val="000000">
+                <a:alpha val="22000"/>
+              </a:srgbClr>
+            </a:outerShdw>
+          </a:effectLst>
+        </p:spPr>
+      </p:sp>
+      <p:sp>
+        <p:nvSpPr>
+          <p:cNvPr id="21" name="Text 19"/>
+          <p:cNvSpPr/>
+          <p:nvPr/>
+        </p:nvSpPr>
+        <p:spPr>
+          <a:xfrm>
+            <a:off x="7498080" y="4594860"/>
+            <a:ext cx="1783080" cy="658368"/>
+          </a:xfrm>
+          <a:prstGeom prst="rect">
+            <a:avLst/>
+          </a:prstGeom>
+          <a:noFill/>
+          <a:ln/>
+        </p:spPr>
+        <p:txBody>
+          <a:bodyPr wrap="square" lIns="0" tIns="0" rIns="0" bIns="0" rtlCol="0" anchor="ctr"/>
+          <a:lstStyle/>
+          <a:p>
+            <a:pPr algn="ctr" indent="0" marL="0">
+              <a:buNone/>
+            </a:pPr>
+            <a:r>
+              <a:rPr lang="en-US" sz="1100" b="1" dirty="0">
+                <a:solidFill>
+                  <a:srgbClr val="F5F9FA"/>
+                </a:solidFill>
+                <a:latin typeface="Calibri" pitchFamily="34" charset="0"/>
+                <a:ea typeface="Calibri" pitchFamily="34" charset="-122"/>
+                <a:cs typeface="Calibri" pitchFamily="34" charset="-120"/>
+              </a:rPr>
+              <a:t>ARIMA Forecast</a:t>
+            </a:r>
+            <a:endParaRPr lang="en-US" sz="1100" dirty="0"/>
+          </a:p>
+        </p:txBody>
+      </p:sp>
+      <p:sp>
+        <p:nvSpPr>
+          <p:cNvPr id="22" name="Shape 20"/>
+          <p:cNvSpPr/>
+          <p:nvPr/>
+        </p:nvSpPr>
+        <p:spPr>
+          <a:xfrm>
+            <a:off x="9692640" y="2560320"/>
+            <a:ext cx="1965960" cy="2286000"/>
+          </a:xfrm>
+          <a:prstGeom prst="roundRect">
+            <a:avLst>
+              <a:gd name="adj" fmla="val 3721"/>
+            </a:avLst>
+          </a:prstGeom>
+          <a:solidFill>
+            <a:srgbClr val="14181C"/>
+          </a:solidFill>
+          <a:ln w="15875">
+            <a:solidFill>
+              <a:srgbClr val="00BCD4"/>
+            </a:solidFill>
+            <a:prstDash val="solid"/>
+          </a:ln>
+          <a:effectLst>
+            <a:outerShdw sx="100000" sy="100000" kx="0" ky="0" algn="bl" rotWithShape="0" blurRad="101600" dist="38100" dir="5400000">
+              <a:srgbClr val="000000">
+                <a:alpha val="28000"/>
+              </a:srgbClr>
+            </a:outerShdw>
+          </a:effectLst>
+        </p:spPr>
+      </p:sp>
+      <p:sp>
+        <p:nvSpPr>
+          <p:cNvPr id="23" name="Text 21"/>
+          <p:cNvSpPr/>
+          <p:nvPr/>
+        </p:nvSpPr>
+        <p:spPr>
+          <a:xfrm>
+            <a:off x="9829800" y="2724912"/>
+            <a:ext cx="1691640" cy="411480"/>
+          </a:xfrm>
+          <a:prstGeom prst="rect">
+            <a:avLst/>
+          </a:prstGeom>
+          <a:noFill/>
+          <a:ln/>
+        </p:spPr>
+        <p:txBody>
+          <a:bodyPr wrap="square" lIns="0" tIns="0" rIns="0" bIns="0" rtlCol="0" anchor="ctr"/>
+          <a:lstStyle/>
+          <a:p>
+            <a:pPr algn="ctr" indent="0" marL="0">
+              <a:buNone/>
+            </a:pPr>
+            <a:r>
+              <a:rPr lang="en-US" sz="1250" b="1" dirty="0">
+                <a:solidFill>
+                  <a:srgbClr val="F5F9FA"/>
+                </a:solidFill>
+                <a:latin typeface="Calibri" pitchFamily="34" charset="0"/>
+                <a:ea typeface="Calibri" pitchFamily="34" charset="-122"/>
+                <a:cs typeface="Calibri" pitchFamily="34" charset="-120"/>
+              </a:rPr>
+              <a:t>Dashboard</a:t>
+            </a:r>
+            <a:endParaRPr lang="en-US" sz="1250" dirty="0"/>
+          </a:p>
+        </p:txBody>
+      </p:sp>
+      <p:sp>
+        <p:nvSpPr>
+          <p:cNvPr id="24" name="Text 22"/>
+          <p:cNvSpPr/>
+          <p:nvPr/>
+        </p:nvSpPr>
+        <p:spPr>
+          <a:xfrm>
+            <a:off x="9829800" y="3127248"/>
+            <a:ext cx="1691640" cy="1572768"/>
+          </a:xfrm>
+          <a:prstGeom prst="rect">
+            <a:avLst/>
+          </a:prstGeom>
+          <a:noFill/>
+          <a:ln/>
+        </p:spPr>
+        <p:txBody>
+          <a:bodyPr wrap="square" lIns="0" tIns="0" rIns="0" bIns="0" rtlCol="0" anchor="ctr"/>
+          <a:lstStyle/>
+          <a:p>
+            <a:pPr algn="ctr" indent="0" marL="0">
+              <a:lnSpc>
+                <a:spcPct val="122000"/>
+              </a:lnSpc>
+              <a:buNone/>
+            </a:pPr>
+            <a:r>
+              <a:rPr lang="en-US" sz="960" dirty="0">
+                <a:solidFill>
+                  <a:srgbClr val="9FB0B8"/>
+                </a:solidFill>
+                <a:latin typeface="Calibri" pitchFamily="34" charset="0"/>
+                <a:ea typeface="Calibri" pitchFamily="34" charset="-122"/>
+                <a:cs typeface="Calibri" pitchFamily="34" charset="-120"/>
+              </a:rPr>
+              <a:t>six Streamlit tabs</a:t>
+            </a:r>
+            <a:endParaRPr lang="en-US" sz="960" dirty="0"/>
+          </a:p>
+          <a:p>
+            <a:pPr algn="ctr" indent="0" marL="0">
+              <a:lnSpc>
+                <a:spcPct val="122000"/>
+              </a:lnSpc>
+              <a:buNone/>
+            </a:pPr>
+            <a:r>
+              <a:rPr lang="en-US" sz="960" dirty="0">
+                <a:solidFill>
+                  <a:srgbClr val="9FB0B8"/>
+                </a:solidFill>
+                <a:latin typeface="Calibri" pitchFamily="34" charset="0"/>
+                <a:ea typeface="Calibri" pitchFamily="34" charset="-122"/>
+                <a:cs typeface="Calibri" pitchFamily="34" charset="-120"/>
+              </a:rPr>
+              <a:t>Plotly charts</a:t>
+            </a:r>
+            <a:endParaRPr lang="en-US" sz="960" dirty="0"/>
+          </a:p>
+          <a:p>
+            <a:pPr algn="ctr" indent="0" marL="0">
+              <a:lnSpc>
+                <a:spcPct val="122000"/>
+              </a:lnSpc>
+              <a:buNone/>
+            </a:pPr>
+            <a:r>
+              <a:rPr lang="en-US" sz="960" dirty="0">
+                <a:solidFill>
+                  <a:srgbClr val="9FB0B8"/>
+                </a:solidFill>
+                <a:latin typeface="Calibri" pitchFamily="34" charset="0"/>
+                <a:ea typeface="Calibri" pitchFamily="34" charset="-122"/>
+                <a:cs typeface="Calibri" pitchFamily="34" charset="-120"/>
+              </a:rPr>
+              <a:t>live / sample</a:t>
+            </a:r>
+            <a:endParaRPr lang="en-US" sz="960" dirty="0"/>
+          </a:p>
+          <a:p>
+            <a:pPr algn="ctr" indent="0" marL="0">
+              <a:lnSpc>
+                <a:spcPct val="122000"/>
+              </a:lnSpc>
+              <a:buNone/>
+            </a:pPr>
+            <a:r>
+              <a:rPr lang="en-US" sz="960" dirty="0">
+                <a:solidFill>
+                  <a:srgbClr val="9FB0B8"/>
+                </a:solidFill>
+                <a:latin typeface="Calibri" pitchFamily="34" charset="0"/>
+                <a:ea typeface="Calibri" pitchFamily="34" charset="-122"/>
+                <a:cs typeface="Calibri" pitchFamily="34" charset="-120"/>
+              </a:rPr>
+              <a:t>badges per feed</a:t>
+            </a:r>
+            <a:endParaRPr lang="en-US" sz="960" dirty="0"/>
+          </a:p>
+        </p:txBody>
+      </p:sp>
+      <p:sp>
+        <p:nvSpPr>
+          <p:cNvPr id="25" name="Shape 23"/>
+          <p:cNvSpPr/>
+          <p:nvPr/>
+        </p:nvSpPr>
+        <p:spPr>
+          <a:xfrm>
+            <a:off x="2551176" y="3703320"/>
+            <a:ext cx="246888" cy="0"/>
+          </a:xfrm>
+          <a:prstGeom prst="line">
+            <a:avLst/>
+          </a:prstGeom>
+          <a:noFill/>
+          <a:ln w="22225">
+            <a:solidFill>
+              <a:srgbClr val="00BCD4"/>
+            </a:solidFill>
+            <a:prstDash val="solid"/>
+            <a:tailEnd type="triangle"/>
+          </a:ln>
+        </p:spPr>
+      </p:sp>
+      <p:sp>
+        <p:nvSpPr>
+          <p:cNvPr id="26" name="Shape 24"/>
+          <p:cNvSpPr/>
+          <p:nvPr/>
+        </p:nvSpPr>
+        <p:spPr>
+          <a:xfrm>
+            <a:off x="4837176" y="3703320"/>
+            <a:ext cx="246888" cy="0"/>
+          </a:xfrm>
+          <a:prstGeom prst="line">
+            <a:avLst/>
+          </a:prstGeom>
+          <a:noFill/>
+          <a:ln w="22225">
+            <a:solidFill>
+              <a:srgbClr val="00BCD4"/>
+            </a:solidFill>
+            <a:prstDash val="solid"/>
+            <a:tailEnd type="triangle"/>
+          </a:ln>
+        </p:spPr>
+      </p:sp>
+      <p:sp>
+        <p:nvSpPr>
+          <p:cNvPr id="27" name="Shape 25"/>
+          <p:cNvSpPr/>
+          <p:nvPr/>
+        </p:nvSpPr>
+        <p:spPr>
+          <a:xfrm>
+            <a:off x="7123176" y="3703320"/>
+            <a:ext cx="246888" cy="0"/>
+          </a:xfrm>
+          <a:prstGeom prst="line">
+            <a:avLst/>
+          </a:prstGeom>
+          <a:noFill/>
+          <a:ln w="22225">
+            <a:solidFill>
+              <a:srgbClr val="00BCD4"/>
+            </a:solidFill>
+            <a:prstDash val="solid"/>
+            <a:tailEnd type="triangle"/>
+          </a:ln>
+        </p:spPr>
+      </p:sp>
+      <p:sp>
+        <p:nvSpPr>
+          <p:cNvPr id="28" name="Shape 26"/>
+          <p:cNvSpPr/>
+          <p:nvPr/>
+        </p:nvSpPr>
+        <p:spPr>
+          <a:xfrm>
+            <a:off x="9409176" y="3703320"/>
+            <a:ext cx="246888" cy="0"/>
+          </a:xfrm>
+          <a:prstGeom prst="line">
+            <a:avLst/>
+          </a:prstGeom>
+          <a:noFill/>
+          <a:ln w="22225">
+            <a:solidFill>
+              <a:srgbClr val="00BCD4"/>
+            </a:solidFill>
+            <a:prstDash val="solid"/>
+            <a:tailEnd type="triangle"/>
+          </a:ln>
+        </p:spPr>
+      </p:sp>
+      <p:sp>
+        <p:nvSpPr>
+          <p:cNvPr id="29" name="Shape 27"/>
+          <p:cNvSpPr/>
+          <p:nvPr/>
+        </p:nvSpPr>
+        <p:spPr>
+          <a:xfrm>
+            <a:off x="548640" y="5349240"/>
+            <a:ext cx="11091672" cy="777240"/>
+          </a:xfrm>
+          <a:prstGeom prst="roundRect">
+            <a:avLst>
+              <a:gd name="adj" fmla="val 9412"/>
+            </a:avLst>
+          </a:prstGeom>
+          <a:solidFill>
+            <a:srgbClr val="F1F5F6"/>
+          </a:solidFill>
+          <a:ln/>
+        </p:spPr>
+      </p:sp>
+      <p:sp>
+        <p:nvSpPr>
+          <p:cNvPr id="30" name="Text 28"/>
+          <p:cNvSpPr/>
+          <p:nvPr/>
+        </p:nvSpPr>
+        <p:spPr>
+          <a:xfrm>
+            <a:off x="822960" y="5349240"/>
+            <a:ext cx="10515600" cy="777240"/>
+          </a:xfrm>
+          <a:prstGeom prst="rect">
+            <a:avLst/>
+          </a:prstGeom>
+          <a:noFill/>
+          <a:ln/>
+        </p:spPr>
+        <p:txBody>
+          <a:bodyPr wrap="square" lIns="0" tIns="0" rIns="0" bIns="0" rtlCol="0" anchor="ctr"/>
+          <a:lstStyle/>
+          <a:p>
+            <a:pPr indent="0" marL="0">
+              <a:buNone/>
+            </a:pPr>
+            <a:r>
+              <a:rPr lang="en-US" sz="1250" i="1" dirty="0">
+                <a:solidFill>
+                  <a:srgbClr val="16202A"/>
+                </a:solidFill>
+                <a:latin typeface="Calibri" pitchFamily="34" charset="0"/>
+                <a:ea typeface="Calibri" pitchFamily="34" charset="-122"/>
+                <a:cs typeface="Calibri" pitchFamily="34" charset="-120"/>
+              </a:rPr>
+              <a:t>Each analysis reads the same bundle and depends on nothing else — a fifth one could be added without touching a single data loader.</a:t>
+            </a:r>
+            <a:endParaRPr lang="en-US" sz="1250" dirty="0"/>
+          </a:p>
+        </p:txBody>
+      </p:sp>
+      <p:sp>
+        <p:nvSpPr>
+          <p:cNvPr id="31" name="Text 29"/>
           <p:cNvSpPr/>
           <p:nvPr/>
         </p:nvSpPr>
@@ -15286,7 +16538,7 @@
       </p:sp>
       <p:sp>
         <p:nvSpPr>
-          <p:cNvPr id="7" name="Text 4"/>
+          <p:cNvPr id="32" name="Text 30"/>
           <p:cNvSpPr/>
           <p:nvPr/>
         </p:nvSpPr>

</xml_diff>